<commit_message>
runs all the program sucessfully
</commit_message>
<xml_diff>
--- a/posters/carbon_aware_ml_academic_posters_v2.pptx
+++ b/posters/carbon_aware_ml_academic_posters_v2.pptx
@@ -519,19 +519,19 @@
                 <c:formatCode>General</c:formatCode>
                 <c:ptCount val="5"/>
                 <c:pt idx="0">
-                  <c:v>0.91</c:v>
+                  <c:v>0.37</c:v>
                 </c:pt>
                 <c:pt idx="1">
-                  <c:v>5.06</c:v>
+                  <c:v>0.23</c:v>
                 </c:pt>
                 <c:pt idx="2">
-                  <c:v>6.59</c:v>
+                  <c:v>5.69</c:v>
                 </c:pt>
                 <c:pt idx="3">
-                  <c:v>11.01</c:v>
+                  <c:v>4.71</c:v>
                 </c:pt>
                 <c:pt idx="4">
-                  <c:v>28.44</c:v>
+                  <c:v>7.07</c:v>
                 </c:pt>
               </c:numCache>
             </c:numRef>
@@ -1017,19 +1017,19 @@
                 <c:formatCode>General</c:formatCode>
                 <c:ptCount val="5"/>
                 <c:pt idx="0">
-                  <c:v>0.91</c:v>
+                  <c:v>0.37</c:v>
                 </c:pt>
                 <c:pt idx="1">
-                  <c:v>5.06</c:v>
+                  <c:v>0.23</c:v>
                 </c:pt>
                 <c:pt idx="2">
-                  <c:v>6.59</c:v>
+                  <c:v>5.69</c:v>
                 </c:pt>
                 <c:pt idx="3">
-                  <c:v>11.01</c:v>
+                  <c:v>4.71</c:v>
                 </c:pt>
                 <c:pt idx="4">
-                  <c:v>28.44</c:v>
+                  <c:v>7.07</c:v>
                 </c:pt>
               </c:numCache>
             </c:numRef>
@@ -1515,19 +1515,19 @@
                 <c:formatCode>General</c:formatCode>
                 <c:ptCount val="5"/>
                 <c:pt idx="0">
-                  <c:v>0.91</c:v>
+                  <c:v>0.37</c:v>
                 </c:pt>
                 <c:pt idx="1">
-                  <c:v>5.06</c:v>
+                  <c:v>0.23</c:v>
                 </c:pt>
                 <c:pt idx="2">
-                  <c:v>6.59</c:v>
+                  <c:v>5.69</c:v>
                 </c:pt>
                 <c:pt idx="3">
-                  <c:v>11.01</c:v>
+                  <c:v>4.71</c:v>
                 </c:pt>
                 <c:pt idx="4">
-                  <c:v>28.44</c:v>
+                  <c:v>7.07</c:v>
                 </c:pt>
               </c:numCache>
             </c:numRef>

</xml_diff>